<commit_message>
Trim redundant section-name prefixes; add GitHub QR code to poster
Motivation/Problem Setting bullets repeated their own section header
as a text prefix ("Motivation: ..." under a heading already reading
"Motivation") -- dropped the redundant prefixes for faster reading.
Also adds a QR code (linking to this repo) plus a short caption in the
empty space at the bottom of the Future Works section.

Co-Authored-By: Claude Sonnet 5 <noreply@anthropic.com>
</commit_message>
<xml_diff>
--- a/poster/poster_fixed.pptx
+++ b/poster/poster_fixed.pptx
@@ -6606,7 +6606,7 @@
                 <a:cs typeface="IBM Plex Sans"/>
                 <a:sym typeface="IBM Plex Sans"/>
               </a:rPr>
-              <a:t>Motivation: Sparse, binary rewards are the most natural way to specify a robotic task — but they give the agent no signal on how to improve (Andrychowicz et al., 2017)</a:t>
+              <a:t>Sparse, binary rewards are the most natural way to specify a robotic task — but they give the agent no signal on how to improve (Andrychowicz et al., 2017)</a:t>
             </a:r>
             <a:endParaRPr sz="4300">
               <a:solidFill>
@@ -6646,7 +6646,7 @@
                 <a:cs typeface="IBM Plex Sans"/>
                 <a:sym typeface="IBM Plex Sans"/>
               </a:rPr>
-              <a:t>Motivation: HER is known to help under sparse rewards — but when it matters most and why it works is unclear</a:t>
+              <a:t>HER is known to help under sparse rewards — but when it matters most and why it works is unclear</a:t>
             </a:r>
             <a:endParaRPr sz="4300">
               <a:solidFill>
@@ -7315,7 +7315,7 @@
                 <a:cs typeface="IBM Plex Sans"/>
                 <a:sym typeface="IBM Plex Sans"/>
               </a:rPr>
-              <a:t>Problem Setting: Does HER's benefit scale with task difficulty, and what training-dynamics mechanism drives it?</a:t>
+              <a:t>Does HER's benefit scale with task difficulty, and what training-dynamics mechanism drives it?</a:t>
             </a:r>
             <a:endParaRPr sz="4300">
               <a:latin typeface="IBM Plex Sans"/>
@@ -7542,6 +7542,73 @@
           </a:prstGeom>
         </p:spPr>
       </p:pic>
+      <p:pic>
+        <p:nvPicPr>
+          <p:cNvPr id="86" name="Picture 85" descr="qr_repo.png"/>
+          <p:cNvPicPr>
+            <a:picLocks noChangeAspect="1"/>
+          </p:cNvPicPr>
+          <p:nvPr/>
+        </p:nvPicPr>
+        <p:blipFill>
+          <a:blip r:embed="rId8"/>
+          <a:stretch>
+            <a:fillRect/>
+          </a:stretch>
+        </p:blipFill>
+        <p:spPr>
+          <a:xfrm>
+            <a:off x="540000" y="36345172"/>
+            <a:ext cx="2011680" cy="2011680"/>
+          </a:xfrm>
+          <a:prstGeom prst="rect">
+            <a:avLst/>
+          </a:prstGeom>
+        </p:spPr>
+      </p:pic>
+      <p:sp>
+        <p:nvSpPr>
+          <p:cNvPr id="87" name="TextBox 86"/>
+          <p:cNvSpPr txBox="1"/>
+          <p:nvPr/>
+        </p:nvSpPr>
+        <p:spPr>
+          <a:xfrm>
+            <a:off x="2751680" y="36345172"/>
+            <a:ext cx="8566720" cy="2011680"/>
+          </a:xfrm>
+          <a:prstGeom prst="rect">
+            <a:avLst/>
+          </a:prstGeom>
+          <a:noFill/>
+        </p:spPr>
+        <p:txBody>
+          <a:bodyPr wrap="square">
+            <a:spAutoFit/>
+          </a:bodyPr>
+          <a:lstStyle/>
+          <a:p>
+            <a:r>
+              <a:rPr sz="1400" b="1">
+                <a:solidFill>
+                  <a:srgbClr val="0B5394"/>
+                </a:solidFill>
+              </a:rPr>
+              <a:t>Code, data &amp; full report</a:t>
+            </a:r>
+          </a:p>
+          <a:p>
+            <a:r>
+              <a:rPr sz="1100">
+                <a:solidFill>
+                  <a:srgbClr val="404040"/>
+                </a:solidFill>
+              </a:rPr>
+              <a:t>github.com/mustafa99705/-adrl-sac-her-fetchreach</a:t>
+            </a:r>
+          </a:p>
+        </p:txBody>
+      </p:sp>
     </p:spTree>
   </p:cSld>
   <p:clrMapOvr>

</xml_diff>

<commit_message>
Add simulation setup image to the poster's Approach section
Renders one held-out episode of the trained sparse+HER Push policy
(results/videos/push_sparse_her.mp4, seed2 -- a clean 100%-success
run) since only Reach videos existed before. Extracts the start frame
from each task's video (clearest illustration of the setup: Reach
shows only the goal marker, Push additionally shows the object to
push) and combines them side by side with labels into the empty space
in the Approach section.

Co-Authored-By: Claude Sonnet 5 <noreply@anthropic.com>
</commit_message>
<xml_diff>
--- a/poster/poster_fixed.pptx
+++ b/poster/poster_fixed.pptx
@@ -7609,6 +7609,30 @@
           </a:p>
         </p:txBody>
       </p:sp>
+      <p:pic>
+        <p:nvPicPr>
+          <p:cNvPr id="88" name="Picture 87" descr="sim_combined.png"/>
+          <p:cNvPicPr>
+            <a:picLocks noChangeAspect="1"/>
+          </p:cNvPicPr>
+          <p:nvPr/>
+        </p:nvPicPr>
+        <p:blipFill>
+          <a:blip r:embed="rId9"/>
+          <a:stretch>
+            <a:fillRect/>
+          </a:stretch>
+        </p:blipFill>
+        <p:spPr>
+          <a:xfrm>
+            <a:off x="540000" y="26123300"/>
+            <a:ext cx="9636400" cy="5300000"/>
+          </a:xfrm>
+          <a:prstGeom prst="rect">
+            <a:avLst/>
+          </a:prstGeom>
+        </p:spPr>
+      </p:pic>
     </p:spTree>
   </p:cSld>
   <p:clrMapOvr>

</xml_diff>

<commit_message>
Add ablation figure to the poster's Key Insights section
Fills the remaining empty space below the entropy plot with
fig6_push_ablation.pdf, giving visual support to the existing
"More relabeling saturates, doesn't compound" bullet.

Co-Authored-By: Claude Sonnet 5 <noreply@anthropic.com>
</commit_message>
<xml_diff>
--- a/poster/poster_fixed.pptx
+++ b/poster/poster_fixed.pptx
@@ -7633,6 +7633,30 @@
           </a:prstGeom>
         </p:spPr>
       </p:pic>
+      <p:pic>
+        <p:nvPicPr>
+          <p:cNvPr id="89" name="Picture 88" descr="fig6_push_ablation-1.png"/>
+          <p:cNvPicPr>
+            <a:picLocks noChangeAspect="1"/>
+          </p:cNvPicPr>
+          <p:nvPr/>
+        </p:nvPicPr>
+        <p:blipFill>
+          <a:blip r:embed="rId10"/>
+          <a:stretch>
+            <a:fillRect/>
+          </a:stretch>
+        </p:blipFill>
+        <p:spPr>
+          <a:xfrm>
+            <a:off x="12151200" y="32071573"/>
+            <a:ext cx="14000000" cy="9000000"/>
+          </a:xfrm>
+          <a:prstGeom prst="rect">
+            <a:avLst/>
+          </a:prstGeom>
+        </p:spPr>
+      </p:pic>
     </p:spTree>
   </p:cSld>
   <p:clrMapOvr>

</xml_diff>

<commit_message>
Re-render simulation images at print resolution (480px -> 2000px)
The original sim images were extracted from the compressed 480x480
training video and stretched to ~11in wide on the poster (~43 DPI --
would print blurry on a real poster). Re-rendered the same reset-state
frames directly from MuJoCo at 2000x2000 via env.render(), matching
the ~300 DPI quality of the other poster figures.

Co-Authored-By: Claude Sonnet 5 <noreply@anthropic.com>
</commit_message>
<xml_diff>
--- a/poster/poster_fixed.pptx
+++ b/poster/poster_fixed.pptx
@@ -7611,30 +7611,6 @@
       </p:sp>
       <p:pic>
         <p:nvPicPr>
-          <p:cNvPr id="88" name="Picture 87" descr="sim_combined.png"/>
-          <p:cNvPicPr>
-            <a:picLocks noChangeAspect="1"/>
-          </p:cNvPicPr>
-          <p:nvPr/>
-        </p:nvPicPr>
-        <p:blipFill>
-          <a:blip r:embed="rId9"/>
-          <a:stretch>
-            <a:fillRect/>
-          </a:stretch>
-        </p:blipFill>
-        <p:spPr>
-          <a:xfrm>
-            <a:off x="540000" y="26123300"/>
-            <a:ext cx="9636400" cy="5300000"/>
-          </a:xfrm>
-          <a:prstGeom prst="rect">
-            <a:avLst/>
-          </a:prstGeom>
-        </p:spPr>
-      </p:pic>
-      <p:pic>
-        <p:nvPicPr>
           <p:cNvPr id="89" name="Picture 88" descr="fig6_push_ablation-1.png"/>
           <p:cNvPicPr>
             <a:picLocks noChangeAspect="1"/>
@@ -7651,6 +7627,30 @@
           <a:xfrm>
             <a:off x="12151200" y="32071573"/>
             <a:ext cx="14000000" cy="9000000"/>
+          </a:xfrm>
+          <a:prstGeom prst="rect">
+            <a:avLst/>
+          </a:prstGeom>
+        </p:spPr>
+      </p:pic>
+      <p:pic>
+        <p:nvPicPr>
+          <p:cNvPr id="90" name="Picture 89" descr="sim_combined.png"/>
+          <p:cNvPicPr>
+            <a:picLocks noChangeAspect="1"/>
+          </p:cNvPicPr>
+          <p:nvPr/>
+        </p:nvPicPr>
+        <p:blipFill>
+          <a:blip r:embed="rId11"/>
+          <a:stretch>
+            <a:fillRect/>
+          </a:stretch>
+        </p:blipFill>
+        <p:spPr>
+          <a:xfrm>
+            <a:off x="540000" y="26123300"/>
+            <a:ext cx="9967710" cy="5300000"/>
           </a:xfrm>
           <a:prstGeom prst="rect">
             <a:avLst/>

</xml_diff>

<commit_message>
Add a short References line to the poster
Andrychowicz et al. 2017 (HER) and Haarnoja et al. 2018 (SAC),
placed below the QR code in the Future Works section's remaining
empty space.

Co-Authored-By: Claude Sonnet 5 <noreply@anthropic.com>
</commit_message>
<xml_diff>
--- a/poster/poster_fixed.pptx
+++ b/poster/poster_fixed.pptx
@@ -7657,6 +7657,59 @@
           </a:prstGeom>
         </p:spPr>
       </p:pic>
+      <p:sp>
+        <p:nvSpPr>
+          <p:cNvPr id="91" name="TextBox 90"/>
+          <p:cNvSpPr txBox="1"/>
+          <p:nvPr/>
+        </p:nvSpPr>
+        <p:spPr>
+          <a:xfrm>
+            <a:off x="540000" y="38556852"/>
+            <a:ext cx="10984200" cy="1400000"/>
+          </a:xfrm>
+          <a:prstGeom prst="rect">
+            <a:avLst/>
+          </a:prstGeom>
+          <a:noFill/>
+        </p:spPr>
+        <p:txBody>
+          <a:bodyPr wrap="square">
+            <a:spAutoFit/>
+          </a:bodyPr>
+          <a:lstStyle/>
+          <a:p>
+            <a:r>
+              <a:rPr sz="1300" b="1">
+                <a:solidFill>
+                  <a:srgbClr val="0B5394"/>
+                </a:solidFill>
+              </a:rPr>
+              <a:t>References</a:t>
+            </a:r>
+          </a:p>
+          <a:p>
+            <a:r>
+              <a:rPr sz="1100">
+                <a:solidFill>
+                  <a:srgbClr val="404040"/>
+                </a:solidFill>
+              </a:rPr>
+              <a:t>Andrychowicz et al., Hindsight Experience Replay, NeurIPS 2017</a:t>
+            </a:r>
+          </a:p>
+          <a:p>
+            <a:r>
+              <a:rPr sz="1100">
+                <a:solidFill>
+                  <a:srgbClr val="404040"/>
+                </a:solidFill>
+              </a:rPr>
+              <a:t>Haarnoja et al., Soft Actor-Critic, ICML 2018</a:t>
+            </a:r>
+          </a:p>
+        </p:txBody>
+      </p:sp>
     </p:spTree>
   </p:cSld>
   <p:clrMapOvr>

</xml_diff>

<commit_message>
Add experimental-design grid to fill empty space under Problem Setting
4 conditions x 2 tasks grid (dense/dense+HER/sparse/sparse+HER x
Reach/Push), color-matched to the other figures' condition palette,
showing which conditions actually ran on which task (Push only used
sparse and sparse+HER per the proposal's scope). Fills the visual
imbalance the user spotted: every other section already had a figure,
this one didn't.

Co-Authored-By: Claude Sonnet 5 <noreply@anthropic.com>
</commit_message>
<xml_diff>
--- a/poster/poster_fixed.pptx
+++ b/poster/poster_fixed.pptx
@@ -7710,6 +7710,30 @@
           </a:p>
         </p:txBody>
       </p:sp>
+      <p:pic>
+        <p:nvPicPr>
+          <p:cNvPr id="92" name="Picture 91" descr="design_grid.png"/>
+          <p:cNvPicPr>
+            <a:picLocks noChangeAspect="1"/>
+          </p:cNvPicPr>
+          <p:nvPr/>
+        </p:nvPicPr>
+        <p:blipFill>
+          <a:blip r:embed="rId12"/>
+          <a:stretch>
+            <a:fillRect/>
+          </a:stretch>
+        </p:blipFill>
+        <p:spPr>
+          <a:xfrm>
+            <a:off x="21920100" y="13027800"/>
+            <a:ext cx="7414600" cy="5566577"/>
+          </a:xfrm>
+          <a:prstGeom prst="rect">
+            <a:avLst/>
+          </a:prstGeom>
+        </p:spPr>
+      </p:pic>
     </p:spTree>
   </p:cSld>
   <p:clrMapOvr>

</xml_diff>